<commit_message>
Write DSATUR and largest_first colouring by hand
The task asks for a distance-2 colouring algorithm to be written, so the
colouring no longer calls networkx's greedy_color. graph_engine.py now
implements both strategies directly. Tests check that they give exactly
the same colourings as networkx on random layouts, so the grid schedule
and the recorded EMANE results are unchanged.

Docs, README and slides updated to match (98 tests).
</commit_message>
<xml_diff>
--- a/presentation.pptx
+++ b/presentation.pptx
@@ -119,13 +119,13 @@
   <p:extLst>
     <p:ext uri="{521415D9-36F7-43E2-AB2F-B90AF26B5E84}">
       <p14:sectionLst xmlns:p14="http://schemas.microsoft.com/office/powerpoint/2010/main">
-        <p14:section name="Introduction" id="{f1edbd73-83db-5687-5870-f940a62808eb}">
+        <p14:section name="Introduction" id="{b358647a-90cf-b7d3-fb61-b1b5da8c0118}">
           <p14:sldIdLst>
             <p14:sldId id="256"/>
             <p14:sldId id="257"/>
           </p14:sldIdLst>
         </p14:section>
-        <p14:section name="Part 1" id="{0b1ebb02-5120-367d-ce2c-95ce3acb643e}">
+        <p14:section name="Part 1" id="{df0ac25a-3a49-edc2-abdf-fac24a05af23}">
           <p14:sldIdLst>
             <p14:sldId id="258"/>
             <p14:sldId id="259"/>
@@ -134,7 +134,7 @@
             <p14:sldId id="262"/>
           </p14:sldIdLst>
         </p14:section>
-        <p14:section name="Part 2" id="{aecfd2f9-7e82-d757-43c4-7dd63511e32f}">
+        <p14:section name="Part 2" id="{6d403b89-67b1-078a-5bd4-0ad0b0b008d4}">
           <p14:sldIdLst>
             <p14:sldId id="263"/>
             <p14:sldId id="264"/>
@@ -142,7 +142,7 @@
             <p14:sldId id="266"/>
           </p14:sldIdLst>
         </p14:section>
-        <p14:section name="Wrap-up" id="{2cddc199-8957-dc03-7dde-02190a0a1192}">
+        <p14:section name="Wrap-up" id="{ce2b6c4a-5dcd-a9d1-3602-21580af9cf22}">
           <p14:sldIdLst>
             <p14:sldId id="267"/>
             <p14:sldId id="268"/>
@@ -1905,7 +1905,7 @@
           <a:p>
             <a:r>
               <a:rPr lang="en-US" dirty="0"/>
-              <a:t>Greedy colouring never collides; only the visiting order changes how many slots it needs. DSATUR adapts as it goes and is usually better, more so on bigger networks. largest_first still wins sometimes, so the tool runs both. Numbers are from 500 random layouts per size in a 2 km square.</a:t>
+              <a:t>Greedy colouring never collides; only the visiting order changes how many slots it needs. Both are written by hand in graph_engine.py and checked against networkx. DSATUR adapts as it goes and is usually better, more so on bigger networks. largest_first still wins sometimes, so the tool runs both. Numbers are from 500 random layouts per size in a 2 km square.</a:t>
             </a:r>
             <a:endParaRPr lang="en-US" dirty="0"/>
           </a:p>
@@ -2169,7 +2169,7 @@
           <a:p>
             <a:r>
               <a:rPr lang="en-US" dirty="0"/>
-              <a:t>Two layers. Inside the tool, the validator recomputes interference from coordinates and never looks at the conflict graph, so a bug in graph construction cannot hide a collision. Outside the tool, 57 pytest tests cover the edge cases the task implies.</a:t>
+              <a:t>Two layers. Inside the tool, the validator recomputes interference from coordinates and never looks at the conflict graph, so a bug in graph construction cannot hide a collision. Outside the tool, 98 pytest tests cover the edge cases the task implies, and check the hand-written colouring against networkx.</a:t>
             </a:r>
             <a:endParaRPr lang="en-US" dirty="0"/>
           </a:p>
@@ -10786,7 +10786,7 @@
                   <a:schemeClr val="accent3"/>
                 </a:solidFill>
               </a:rPr>
-              <a:t>Each colour is a slot. Run DSATUR and largest_first, keep the shorter.</a:t>
+              <a:t>Each colour is a slot. Hand-written DSATUR and largest_first.</a:t>
             </a:r>
             <a:endParaRPr lang="en-US" sz="1200" dirty="0"/>
           </a:p>
@@ -16389,7 +16389,7 @@
                   <a:schemeClr val="tx1"/>
                 </a:solidFill>
               </a:rPr>
-              <a:t>57 automated tests</a:t>
+              <a:t>98 automated tests</a:t>
             </a:r>
             <a:endParaRPr lang="en-US" sz="1600" dirty="0"/>
           </a:p>
@@ -16538,6 +16538,24 @@
                 </a:solidFill>
               </a:rPr>
               <a:t>Validator catches direct and hidden-terminal collisions</a:t>
+            </a:r>
+            <a:endParaRPr lang="en-US" sz="1200" dirty="0"/>
+          </a:p>
+          <a:p>
+            <a:pPr marL="342900" indent="-342900">
+              <a:spcAft>
+                <a:spcPts val="600"/>
+              </a:spcAft>
+              <a:buSzPct val="100000"/>
+              <a:buChar char="•"/>
+            </a:pPr>
+            <a:r>
+              <a:rPr lang="en-US" sz="1200" dirty="0">
+                <a:solidFill>
+                  <a:schemeClr val="accent3"/>
+                </a:solidFill>
+              </a:rPr>
+              <a:t>Hand-written DSATUR matches networkx exactly</a:t>
             </a:r>
             <a:endParaRPr lang="en-US" sz="1200" dirty="0"/>
           </a:p>

</xml_diff>

<commit_message>
Set document subject in PDF and slide metadata
</commit_message>
<xml_diff>
--- a/presentation.pptx
+++ b/presentation.pptx
@@ -119,13 +119,13 @@
   <p:extLst>
     <p:ext uri="{521415D9-36F7-43E2-AB2F-B90AF26B5E84}">
       <p14:sectionLst xmlns:p14="http://schemas.microsoft.com/office/powerpoint/2010/main">
-        <p14:section name="Introduction" id="{b358647a-90cf-b7d3-fb61-b1b5da8c0118}">
+        <p14:section name="Introduction" id="{d299f75c-c817-b4b8-1648-415f480204e8}">
           <p14:sldIdLst>
             <p14:sldId id="256"/>
             <p14:sldId id="257"/>
           </p14:sldIdLst>
         </p14:section>
-        <p14:section name="Part 1" id="{df0ac25a-3a49-edc2-abdf-fac24a05af23}">
+        <p14:section name="Part 1" id="{d9c296a7-dcce-fc4e-fd3a-890de80131ab}">
           <p14:sldIdLst>
             <p14:sldId id="258"/>
             <p14:sldId id="259"/>
@@ -134,7 +134,7 @@
             <p14:sldId id="262"/>
           </p14:sldIdLst>
         </p14:section>
-        <p14:section name="Part 2" id="{6d403b89-67b1-078a-5bd4-0ad0b0b008d4}">
+        <p14:section name="Part 2" id="{a96454e6-aacf-d447-74b5-5b0870a13d08}">
           <p14:sldIdLst>
             <p14:sldId id="263"/>
             <p14:sldId id="264"/>
@@ -142,7 +142,7 @@
             <p14:sldId id="266"/>
           </p14:sldIdLst>
         </p14:section>
-        <p14:section name="Wrap-up" id="{ce2b6c4a-5dcd-a9d1-3602-21580af9cf22}">
+        <p14:section name="Wrap-up" id="{c6eb2217-6de2-2b00-20ab-9ae9f13d0a4a}">
           <p14:sldIdLst>
             <p14:sldId id="267"/>
             <p14:sldId id="268"/>

</xml_diff>